<commit_message>
Fix PowerPoint Morph transition
</commit_message>
<xml_diff>
--- a/presentations/Morph_Uebergang_Demo_3_Schritte.pptx
+++ b/presentations/Morph_Uebergang_Demo_3_Schritte.pptx
@@ -3839,7 +3839,7 @@
 </file>
 
 <file path=ppt/slides/slide2.xml><?xml version="1.0" encoding="utf-8"?>
-<p:sld xmlns:p="http://schemas.openxmlformats.org/presentationml/2006/main" xmlns:p14="http://schemas.microsoft.com/office/powerpoint/2010/main">
+<p:sld xmlns:p="http://schemas.openxmlformats.org/presentationml/2006/main">
   <p:cSld>
     <p:bg>
       <p:bgPr>
@@ -4927,9 +4927,18 @@
       </p:ext>
     </p:extLst>
   </p:cSld>
-  <p:transition spd="med" advClick="1">
-    <p14:morph option="byObject"/>
-  </p:transition>
+  <mc:AlternateContent xmlns:mc="http://schemas.openxmlformats.org/markup-compatibility/2006">
+    <mc:Choice xmlns:p159="http://schemas.microsoft.com/office/powerpoint/2015/09/main" Requires="p159">
+      <p:transition xmlns:p14="http://schemas.microsoft.com/office/powerpoint/2010/main" spd="slow" p14:dur="1000" advClick="1">
+        <p159:morph option="byObject"/>
+      </p:transition>
+    </mc:Choice>
+    <mc:Fallback>
+      <p:transition spd="slow" advClick="1">
+        <p:fade/>
+      </p:transition>
+    </mc:Fallback>
+  </mc:AlternateContent>
 </p:sld>
 </file>
 

</xml_diff>